<commit_message>
Add verification methodology section to report and PPTX (17 slides)
New section 7: "Verification: Why Strict Testing Matters for Agentic Development"
- Correlation metric: input-invariant, pattern-sensitive, caught Flash Attention
  bug that element-wise tolerance missed (corr=0.13 but PASS!)
- Correlation limitation: constant bias invisible (GEMM rounding mode bug,
  mean_error=-165 but corr=0.9999). Need BOTH correlation AND tolerance.
- Full verification stack: correlation + tolerance + bias + end-to-end + exact
- Compiler fuzzing: shape sweeps (GEMM 4 shapes x 12 tiles, GEMV 5 shapes x
  4 flags, Flash Attention 10 configs)
- Test input strategy: randn*4 not arange, seed=42, real LLAMA weights
- Per-layer verification: 240+ correlation checks per inference via --verify

PPTX updated to 17 slides (two new verification slides: 12-13).

Co-Authored-By: Claude Opus 4.6 <noreply@anthropic.com>
</commit_message>
<xml_diff>
--- a/programming_examples/llama3/docs/report/llama_report.pptx
+++ b/programming_examples/llama3/docs/report/llama_report.pptx
@@ -26,6 +26,8 @@
     <p:sldId id="268" r:id="rId34"/>
     <p:sldId id="269" r:id="rId35"/>
     <p:sldId id="270" r:id="rId36"/>
+    <p:sldId id="271" r:id="rId37"/>
+    <p:sldId id="272" r:id="rId38"/>
   </p:sldIdLst>
   <p:sldSz cx="12192000" cy="6858000"/>
   <p:notesSz cx="6858000" cy="9144000"/>
@@ -20326,7 +20328,7 @@
           <a:lstStyle/>
           <a:p>
             <a:r>
-              <a:t>Methodology: Documentation-Driven Development</a:t>
+              <a:t>Strict Verification for Agentic Development</a:t>
             </a:r>
           </a:p>
         </p:txBody>
@@ -20347,10 +20349,10 @@
           <a:lstStyle/>
           <a:p>
             <a:pPr>
-              <a:defRPr sz="1300"/>
+              <a:defRPr sz="1300" b="1"/>
             </a:pPr>
             <a:r>
-              <a:t>Structured approach across multiple working sessions:</a:t>
+              <a:t>With AI-assisted development, false positives are the biggest risk</a:t>
             </a:r>
           </a:p>
           <a:p>
@@ -20380,7 +20382,7 @@
                   <a:srgbClr val="ED1C24"/>
                 </a:solidFill>
               </a:rPr>
-              <a:t>Phased roadmap with clear entry/exit criteria</a:t>
+              <a:t>Correlation: the key metric (input-invariant, pattern-sensitive)</a:t>
             </a:r>
           </a:p>
           <a:p>
@@ -20395,7 +20397,7 @@
             </a:pPr>
             <a:r>
               <a:rPr sz="1200" b="0"/>
-              <a:t>Infrastructure -&gt; Kernel validation -&gt; Single layer -&gt; Full model -&gt; Performance</a:t>
+              <a:t>Flash Attention bug: corr=0.13 but element-wise tolerance PASSED (mean_err &lt; atol)</a:t>
             </a:r>
           </a:p>
           <a:p>
@@ -20410,7 +20412,22 @@
             </a:pPr>
             <a:r>
               <a:rPr sz="1200" b="0"/>
-              <a:t>Correctness verified before each performance optimization step</a:t>
+              <a:t>Softmax output clusters around mean(V) regardless of attention pattern</a:t>
+            </a:r>
+          </a:p>
+          <a:p>
+            <a:pPr lvl="1">
+              <a:spcBef>
+                <a:spcPts val="100"/>
+              </a:spcBef>
+              <a:spcAft>
+                <a:spcPts val="400"/>
+              </a:spcAft>
+              <a:defRPr sz="1200"/>
+            </a:pPr>
+            <a:r>
+              <a:rPr sz="1200" b="0"/>
+              <a:t>Correlation detects wrong patterns; tolerance only checks value ranges</a:t>
             </a:r>
           </a:p>
           <a:p>
@@ -20429,7 +20446,7 @@
                   <a:srgbClr val="ED1C24"/>
                 </a:solidFill>
               </a:rPr>
-              <a:t>Living documentation (8+ docs maintained throughout)</a:t>
+              <a:t>When correlation fails: GEMM rounding mode bug</a:t>
             </a:r>
           </a:p>
           <a:p>
@@ -20444,7 +20461,7 @@
             </a:pPr>
             <a:r>
               <a:rPr sz="1200" b="0"/>
-              <a:t>LLAMA_PLAN.md: single-page status overview for session restoration</a:t>
+              <a:t>floor rounding: mean_error=-165 but corr=0.9999 (pattern correct, constant bias)</a:t>
             </a:r>
           </a:p>
           <a:p>
@@ -20459,7 +20476,7 @@
             </a:pPr>
             <a:r>
               <a:rPr sz="1200" b="0"/>
-              <a:t>perf_opt_prefill.md: optimization timeline with per-step measurements</a:t>
+              <a:t>conv_even fix: mean_error=-0.15, errors cancel symmetrically</a:t>
             </a:r>
           </a:p>
           <a:p>
@@ -20474,7 +20491,7 @@
             </a:pPr>
             <a:r>
               <a:rPr sz="1200" b="0"/>
-              <a:t>Per-kernel analysis docs and compiler bug reports with reproducers</a:t>
+              <a:t>Lesson: need BOTH correlation (pattern) AND tolerance (bias) checks</a:t>
             </a:r>
           </a:p>
           <a:p>
@@ -20493,7 +20510,7 @@
                   <a:srgbClr val="ED1C24"/>
                 </a:solidFill>
               </a:rPr>
-              <a:t>Claude Code as development partner</a:t>
+              <a:t>Multi-layer verification: 240+ checks per inference (--verify flag)</a:t>
             </a:r>
           </a:p>
           <a:p>
@@ -20508,7 +20525,7 @@
             </a:pPr>
             <a:r>
               <a:rPr sz="1200" b="0"/>
-              <a:t>Plan mode for design, subagents for parallel exploration, auto-memory for context</a:t>
+              <a:t>Per-step correlation vs CPU F32 reference at every operation in every layer</a:t>
             </a:r>
           </a:p>
           <a:p>
@@ -20523,22 +20540,7 @@
             </a:pPr>
             <a:r>
               <a:rPr sz="1200" b="0"/>
-              <a:t>Iterative loop: change -&gt; compile -&gt; run -&gt; profile -&gt; compare -&gt; decide next</a:t>
-            </a:r>
-          </a:p>
-          <a:p>
-            <a:pPr lvl="1">
-              <a:spcBef>
-                <a:spcPts val="100"/>
-              </a:spcBef>
-              <a:spcAft>
-                <a:spcPts val="400"/>
-              </a:spcAft>
-              <a:defRPr sz="1200"/>
-            </a:pPr>
-            <a:r>
-              <a:rPr sz="1200" b="0"/>
-              <a:t>Documentation-first: each session starts by reading LLAMA_PLAN.md</a:t>
+              <a:t>Catches regressions at the exact operation where they occur</a:t>
             </a:r>
           </a:p>
         </p:txBody>
@@ -20552,6 +20554,941 @@
 </file>
 
 <file path=ppt/slides/slide13.xml><?xml version="1.0" encoding="utf-8"?>
+<p:sld xmlns:a="http://schemas.openxmlformats.org/drawingml/2006/main" xmlns:p="http://schemas.openxmlformats.org/presentationml/2006/main" xmlns:r="http://schemas.openxmlformats.org/officeDocument/2006/relationships">
+  <p:cSld>
+    <p:spTree>
+      <p:nvGrpSpPr>
+        <p:cNvPr id="1" name=""/>
+        <p:cNvGrpSpPr/>
+        <p:nvPr/>
+      </p:nvGrpSpPr>
+      <p:grpSpPr/>
+      <p:sp>
+        <p:nvSpPr>
+          <p:cNvPr id="2" name="Title 1"/>
+          <p:cNvSpPr>
+            <a:spLocks noGrp="1"/>
+          </p:cNvSpPr>
+          <p:nvPr>
+            <p:ph type="title"/>
+          </p:nvPr>
+        </p:nvSpPr>
+        <p:spPr/>
+        <p:txBody>
+          <a:bodyPr/>
+          <a:lstStyle/>
+          <a:p>
+            <a:r>
+              <a:t>Compiler Fuzzing: Shape Sweeps &amp; Config Testing</a:t>
+            </a:r>
+          </a:p>
+        </p:txBody>
+      </p:sp>
+      <p:graphicFrame>
+        <p:nvGraphicFramePr>
+          <p:cNvPr id="3" name="Table 2"/>
+          <p:cNvGraphicFramePr>
+            <a:graphicFrameLocks noGrp="1"/>
+          </p:cNvGraphicFramePr>
+          <p:nvPr/>
+        </p:nvGraphicFramePr>
+        <p:xfrm>
+          <a:off x="457200" y="1280160"/>
+          <a:ext cx="10972800" cy="2560320"/>
+        </p:xfrm>
+        <a:graphic>
+          <a:graphicData uri="http://schemas.openxmlformats.org/drawingml/2006/table">
+            <a:tbl>
+              <a:tblPr firstRow="1" bandRow="1">
+                <a:tableStyleId>{5C22544A-7EE6-4342-B048-85BDC9FD1C3A}</a:tableStyleId>
+              </a:tblPr>
+              <a:tblGrid>
+                <a:gridCol w="1828800"/>
+                <a:gridCol w="2743200"/>
+                <a:gridCol w="2743200"/>
+                <a:gridCol w="3657600"/>
+              </a:tblGrid>
+              <a:tr h="426720">
+                <a:tc>
+                  <a:txBody>
+                    <a:bodyPr/>
+                    <a:lstStyle/>
+                    <a:p>
+                      <a:pPr>
+                        <a:defRPr sz="1100" b="1">
+                          <a:solidFill>
+                            <a:srgbClr val="FFFFFF"/>
+                          </a:solidFill>
+                        </a:defRPr>
+                      </a:pPr>
+                      <a:r>
+                        <a:t>Layer</a:t>
+                      </a:r>
+                    </a:p>
+                  </a:txBody>
+                  <a:tcPr anchor="ctr">
+                    <a:solidFill>
+                      <a:srgbClr val="1A1A2E"/>
+                    </a:solidFill>
+                  </a:tcPr>
+                </a:tc>
+                <a:tc>
+                  <a:txBody>
+                    <a:bodyPr/>
+                    <a:lstStyle/>
+                    <a:p>
+                      <a:pPr>
+                        <a:defRPr sz="1100" b="1">
+                          <a:solidFill>
+                            <a:srgbClr val="FFFFFF"/>
+                          </a:solidFill>
+                        </a:defRPr>
+                      </a:pPr>
+                      <a:r>
+                        <a:t>Metric</a:t>
+                      </a:r>
+                    </a:p>
+                  </a:txBody>
+                  <a:tcPr anchor="ctr">
+                    <a:solidFill>
+                      <a:srgbClr val="1A1A2E"/>
+                    </a:solidFill>
+                  </a:tcPr>
+                </a:tc>
+                <a:tc>
+                  <a:txBody>
+                    <a:bodyPr/>
+                    <a:lstStyle/>
+                    <a:p>
+                      <a:pPr>
+                        <a:defRPr sz="1100" b="1">
+                          <a:solidFill>
+                            <a:srgbClr val="FFFFFF"/>
+                          </a:solidFill>
+                        </a:defRPr>
+                      </a:pPr>
+                      <a:r>
+                        <a:t>Threshold</a:t>
+                      </a:r>
+                    </a:p>
+                  </a:txBody>
+                  <a:tcPr anchor="ctr">
+                    <a:solidFill>
+                      <a:srgbClr val="1A1A2E"/>
+                    </a:solidFill>
+                  </a:tcPr>
+                </a:tc>
+                <a:tc>
+                  <a:txBody>
+                    <a:bodyPr/>
+                    <a:lstStyle/>
+                    <a:p>
+                      <a:pPr>
+                        <a:defRPr sz="1100" b="1">
+                          <a:solidFill>
+                            <a:srgbClr val="FFFFFF"/>
+                          </a:solidFill>
+                        </a:defRPr>
+                      </a:pPr>
+                      <a:r>
+                        <a:t>What It Catches</a:t>
+                      </a:r>
+                    </a:p>
+                  </a:txBody>
+                  <a:tcPr anchor="ctr">
+                    <a:solidFill>
+                      <a:srgbClr val="1A1A2E"/>
+                    </a:solidFill>
+                  </a:tcPr>
+                </a:tc>
+              </a:tr>
+              <a:tr h="426720">
+                <a:tc>
+                  <a:txBody>
+                    <a:bodyPr/>
+                    <a:lstStyle/>
+                    <a:p>
+                      <a:pPr>
+                        <a:defRPr sz="1100">
+                          <a:solidFill>
+                            <a:srgbClr val="000000"/>
+                          </a:solidFill>
+                        </a:defRPr>
+                      </a:pPr>
+                      <a:r>
+                        <a:t>Algorithmic</a:t>
+                      </a:r>
+                    </a:p>
+                  </a:txBody>
+                  <a:tcPr anchor="ctr"/>
+                </a:tc>
+                <a:tc>
+                  <a:txBody>
+                    <a:bodyPr/>
+                    <a:lstStyle/>
+                    <a:p>
+                      <a:pPr>
+                        <a:defRPr sz="1100">
+                          <a:solidFill>
+                            <a:srgbClr val="000000"/>
+                          </a:solidFill>
+                        </a:defRPr>
+                      </a:pPr>
+                      <a:r>
+                        <a:t>Pearson correlation</a:t>
+                      </a:r>
+                    </a:p>
+                  </a:txBody>
+                  <a:tcPr anchor="ctr"/>
+                </a:tc>
+                <a:tc>
+                  <a:txBody>
+                    <a:bodyPr/>
+                    <a:lstStyle/>
+                    <a:p>
+                      <a:pPr>
+                        <a:defRPr sz="1100">
+                          <a:solidFill>
+                            <a:srgbClr val="000000"/>
+                          </a:solidFill>
+                        </a:defRPr>
+                      </a:pPr>
+                      <a:r>
+                        <a:t>corr &gt; 0.99</a:t>
+                      </a:r>
+                    </a:p>
+                  </a:txBody>
+                  <a:tcPr anchor="ctr"/>
+                </a:tc>
+                <a:tc>
+                  <a:txBody>
+                    <a:bodyPr/>
+                    <a:lstStyle/>
+                    <a:p>
+                      <a:pPr>
+                        <a:defRPr sz="1100">
+                          <a:solidFill>
+                            <a:srgbClr val="000000"/>
+                          </a:solidFill>
+                        </a:defRPr>
+                      </a:pPr>
+                      <a:r>
+                        <a:t>Wrong patterns, DMA errors</a:t>
+                      </a:r>
+                    </a:p>
+                  </a:txBody>
+                  <a:tcPr anchor="ctr"/>
+                </a:tc>
+              </a:tr>
+              <a:tr h="426720">
+                <a:tc>
+                  <a:txBody>
+                    <a:bodyPr/>
+                    <a:lstStyle/>
+                    <a:p>
+                      <a:pPr>
+                        <a:defRPr sz="1100">
+                          <a:solidFill>
+                            <a:srgbClr val="000000"/>
+                          </a:solidFill>
+                        </a:defRPr>
+                      </a:pPr>
+                      <a:r>
+                        <a:t>Numerical</a:t>
+                      </a:r>
+                    </a:p>
+                  </a:txBody>
+                  <a:tcPr anchor="ctr">
+                    <a:solidFill>
+                      <a:srgbClr val="F2F2F2"/>
+                    </a:solidFill>
+                  </a:tcPr>
+                </a:tc>
+                <a:tc>
+                  <a:txBody>
+                    <a:bodyPr/>
+                    <a:lstStyle/>
+                    <a:p>
+                      <a:pPr>
+                        <a:defRPr sz="1100">
+                          <a:solidFill>
+                            <a:srgbClr val="000000"/>
+                          </a:solidFill>
+                        </a:defRPr>
+                      </a:pPr>
+                      <a:r>
+                        <a:t>Relative + absolute tol</a:t>
+                      </a:r>
+                    </a:p>
+                  </a:txBody>
+                  <a:tcPr anchor="ctr">
+                    <a:solidFill>
+                      <a:srgbClr val="F2F2F2"/>
+                    </a:solidFill>
+                  </a:tcPr>
+                </a:tc>
+                <a:tc>
+                  <a:txBody>
+                    <a:bodyPr/>
+                    <a:lstStyle/>
+                    <a:p>
+                      <a:pPr>
+                        <a:defRPr sz="1100">
+                          <a:solidFill>
+                            <a:srgbClr val="000000"/>
+                          </a:solidFill>
+                        </a:defRPr>
+                      </a:pPr>
+                      <a:r>
+                        <a:t>rtol=4%, atol=1e-6</a:t>
+                      </a:r>
+                    </a:p>
+                  </a:txBody>
+                  <a:tcPr anchor="ctr">
+                    <a:solidFill>
+                      <a:srgbClr val="F2F2F2"/>
+                    </a:solidFill>
+                  </a:tcPr>
+                </a:tc>
+                <a:tc>
+                  <a:txBody>
+                    <a:bodyPr/>
+                    <a:lstStyle/>
+                    <a:p>
+                      <a:pPr>
+                        <a:defRPr sz="1100">
+                          <a:solidFill>
+                            <a:srgbClr val="000000"/>
+                          </a:solidFill>
+                        </a:defRPr>
+                      </a:pPr>
+                      <a:r>
+                        <a:t>Rounding bias, precision loss</a:t>
+                      </a:r>
+                    </a:p>
+                  </a:txBody>
+                  <a:tcPr anchor="ctr">
+                    <a:solidFill>
+                      <a:srgbClr val="F2F2F2"/>
+                    </a:solidFill>
+                  </a:tcPr>
+                </a:tc>
+              </a:tr>
+              <a:tr h="426720">
+                <a:tc>
+                  <a:txBody>
+                    <a:bodyPr/>
+                    <a:lstStyle/>
+                    <a:p>
+                      <a:pPr>
+                        <a:defRPr sz="1100">
+                          <a:solidFill>
+                            <a:srgbClr val="000000"/>
+                          </a:solidFill>
+                        </a:defRPr>
+                      </a:pPr>
+                      <a:r>
+                        <a:t>Systematic bias</a:t>
+                      </a:r>
+                    </a:p>
+                  </a:txBody>
+                  <a:tcPr anchor="ctr"/>
+                </a:tc>
+                <a:tc>
+                  <a:txBody>
+                    <a:bodyPr/>
+                    <a:lstStyle/>
+                    <a:p>
+                      <a:pPr>
+                        <a:defRPr sz="1100">
+                          <a:solidFill>
+                            <a:srgbClr val="000000"/>
+                          </a:solidFill>
+                        </a:defRPr>
+                      </a:pPr>
+                      <a:r>
+                        <a:t>Mean signed error</a:t>
+                      </a:r>
+                    </a:p>
+                  </a:txBody>
+                  <a:tcPr anchor="ctr"/>
+                </a:tc>
+                <a:tc>
+                  <a:txBody>
+                    <a:bodyPr/>
+                    <a:lstStyle/>
+                    <a:p>
+                      <a:pPr>
+                        <a:defRPr sz="1100">
+                          <a:solidFill>
+                            <a:srgbClr val="000000"/>
+                          </a:solidFill>
+                        </a:defRPr>
+                      </a:pPr>
+                      <a:r>
+                        <a:t>~0</a:t>
+                      </a:r>
+                    </a:p>
+                  </a:txBody>
+                  <a:tcPr anchor="ctr"/>
+                </a:tc>
+                <a:tc>
+                  <a:txBody>
+                    <a:bodyPr/>
+                    <a:lstStyle/>
+                    <a:p>
+                      <a:pPr>
+                        <a:defRPr sz="1100">
+                          <a:solidFill>
+                            <a:srgbClr val="000000"/>
+                          </a:solidFill>
+                        </a:defRPr>
+                      </a:pPr>
+                      <a:r>
+                        <a:t>Hardware rounding defaults</a:t>
+                      </a:r>
+                    </a:p>
+                  </a:txBody>
+                  <a:tcPr anchor="ctr"/>
+                </a:tc>
+              </a:tr>
+              <a:tr h="426720">
+                <a:tc>
+                  <a:txBody>
+                    <a:bodyPr/>
+                    <a:lstStyle/>
+                    <a:p>
+                      <a:pPr>
+                        <a:defRPr sz="1100">
+                          <a:solidFill>
+                            <a:srgbClr val="000000"/>
+                          </a:solidFill>
+                        </a:defRPr>
+                      </a:pPr>
+                      <a:r>
+                        <a:t>End-to-end</a:t>
+                      </a:r>
+                    </a:p>
+                  </a:txBody>
+                  <a:tcPr anchor="ctr">
+                    <a:solidFill>
+                      <a:srgbClr val="F2F2F2"/>
+                    </a:solidFill>
+                  </a:tcPr>
+                </a:tc>
+                <a:tc>
+                  <a:txBody>
+                    <a:bodyPr/>
+                    <a:lstStyle/>
+                    <a:p>
+                      <a:pPr>
+                        <a:defRPr sz="1100">
+                          <a:solidFill>
+                            <a:srgbClr val="000000"/>
+                          </a:solidFill>
+                        </a:defRPr>
+                      </a:pPr>
+                      <a:r>
+                        <a:t>Top-1 prediction</a:t>
+                      </a:r>
+                    </a:p>
+                  </a:txBody>
+                  <a:tcPr anchor="ctr">
+                    <a:solidFill>
+                      <a:srgbClr val="F2F2F2"/>
+                    </a:solidFill>
+                  </a:tcPr>
+                </a:tc>
+                <a:tc>
+                  <a:txBody>
+                    <a:bodyPr/>
+                    <a:lstStyle/>
+                    <a:p>
+                      <a:pPr>
+                        <a:defRPr sz="1100">
+                          <a:solidFill>
+                            <a:srgbClr val="000000"/>
+                          </a:solidFill>
+                        </a:defRPr>
+                      </a:pPr>
+                      <a:r>
+                        <a:t>"Paris"</a:t>
+                      </a:r>
+                    </a:p>
+                  </a:txBody>
+                  <a:tcPr anchor="ctr">
+                    <a:solidFill>
+                      <a:srgbClr val="F2F2F2"/>
+                    </a:solidFill>
+                  </a:tcPr>
+                </a:tc>
+                <a:tc>
+                  <a:txBody>
+                    <a:bodyPr/>
+                    <a:lstStyle/>
+                    <a:p>
+                      <a:pPr>
+                        <a:defRPr sz="1100">
+                          <a:solidFill>
+                            <a:srgbClr val="000000"/>
+                          </a:solidFill>
+                        </a:defRPr>
+                      </a:pPr>
+                      <a:r>
+                        <a:t>Full pipeline integration</a:t>
+                      </a:r>
+                    </a:p>
+                  </a:txBody>
+                  <a:tcPr anchor="ctr">
+                    <a:solidFill>
+                      <a:srgbClr val="F2F2F2"/>
+                    </a:solidFill>
+                  </a:tcPr>
+                </a:tc>
+              </a:tr>
+              <a:tr h="426720">
+                <a:tc>
+                  <a:txBody>
+                    <a:bodyPr/>
+                    <a:lstStyle/>
+                    <a:p>
+                      <a:pPr>
+                        <a:defRPr sz="1100">
+                          <a:solidFill>
+                            <a:srgbClr val="000000"/>
+                          </a:solidFill>
+                        </a:defRPr>
+                      </a:pPr>
+                      <a:r>
+                        <a:t>Exact ops</a:t>
+                      </a:r>
+                    </a:p>
+                  </a:txBody>
+                  <a:tcPr anchor="ctr"/>
+                </a:tc>
+                <a:tc>
+                  <a:txBody>
+                    <a:bodyPr/>
+                    <a:lstStyle/>
+                    <a:p>
+                      <a:pPr>
+                        <a:defRPr sz="1100">
+                          <a:solidFill>
+                            <a:srgbClr val="000000"/>
+                          </a:solidFill>
+                        </a:defRPr>
+                      </a:pPr>
+                      <a:r>
+                        <a:t>rtol=0, atol=0</a:t>
+                      </a:r>
+                    </a:p>
+                  </a:txBody>
+                  <a:tcPr anchor="ctr"/>
+                </a:tc>
+                <a:tc>
+                  <a:txBody>
+                    <a:bodyPr/>
+                    <a:lstStyle/>
+                    <a:p>
+                      <a:pPr>
+                        <a:defRPr sz="1100">
+                          <a:solidFill>
+                            <a:srgbClr val="000000"/>
+                          </a:solidFill>
+                        </a:defRPr>
+                      </a:pPr>
+                      <a:r>
+                        <a:t>Perfect match</a:t>
+                      </a:r>
+                    </a:p>
+                  </a:txBody>
+                  <a:tcPr anchor="ctr"/>
+                </a:tc>
+                <a:tc>
+                  <a:txBody>
+                    <a:bodyPr/>
+                    <a:lstStyle/>
+                    <a:p>
+                      <a:pPr>
+                        <a:defRPr sz="1100">
+                          <a:solidFill>
+                            <a:srgbClr val="000000"/>
+                          </a:solidFill>
+                        </a:defRPr>
+                      </a:pPr>
+                      <a:r>
+                        <a:t>DMA transposes, integer kernels</a:t>
+                      </a:r>
+                    </a:p>
+                  </a:txBody>
+                  <a:tcPr anchor="ctr"/>
+                </a:tc>
+              </a:tr>
+            </a:tbl>
+          </a:graphicData>
+        </a:graphic>
+      </p:graphicFrame>
+      <p:sp>
+        <p:nvSpPr>
+          <p:cNvPr id="4" name="TextBox 3"/>
+          <p:cNvSpPr txBox="1"/>
+          <p:nvPr/>
+        </p:nvSpPr>
+        <p:spPr>
+          <a:xfrm>
+            <a:off x="457200" y="4114800"/>
+            <a:ext cx="10515600" cy="2103120"/>
+          </a:xfrm>
+          <a:prstGeom prst="rect">
+            <a:avLst/>
+          </a:prstGeom>
+          <a:noFill/>
+        </p:spPr>
+        <p:txBody>
+          <a:bodyPr wrap="square">
+            <a:spAutoFit/>
+          </a:bodyPr>
+          <a:lstStyle/>
+          <a:p>
+            <a:pPr>
+              <a:spcAft>
+                <a:spcPts val="300"/>
+              </a:spcAft>
+              <a:defRPr sz="1200" b="0"/>
+            </a:pPr>
+            <a:r>
+              <a:t>Test inputs: randn*4 (not arange!), seed=42, also tested with real LLAMA weights</a:t>
+            </a:r>
+          </a:p>
+          <a:p>
+            <a:pPr>
+              <a:spcAft>
+                <a:spcPts val="300"/>
+              </a:spcAft>
+              <a:defRPr sz="1200" b="0"/>
+            </a:pPr>
+            <a:r>
+              <a:t>GEMM sweep: 4 LLAMA shapes x 12 tile configs, all with correlation + tolerance</a:t>
+            </a:r>
+          </a:p>
+          <a:p>
+            <a:pPr>
+              <a:spcAft>
+                <a:spcPts val="300"/>
+              </a:spcAft>
+              <a:defRPr sz="1200" b="0"/>
+            </a:pPr>
+            <a:r>
+              <a:t>GEMV sweep: 5 shapes x 4 backend flags (tile sizes, pingpong, lock fix)</a:t>
+            </a:r>
+          </a:p>
+          <a:p>
+            <a:pPr>
+              <a:spcAft>
+                <a:spcPts val="300"/>
+              </a:spcAft>
+              <a:defRPr sz="1200" b="0"/>
+            </a:pPr>
+            <a:r>
+              <a:t>Flash Attention sweep: 10 configs (MHA/GQA, causal, varied head counts)</a:t>
+            </a:r>
+          </a:p>
+          <a:p>
+            <a:pPr>
+              <a:spcAft>
+                <a:spcPts val="300"/>
+              </a:spcAft>
+              <a:defRPr sz="1200" b="0"/>
+            </a:pPr>
+            <a:r>
+              <a:t>Tolerance fix: rtol changed from 1.0 (meaningless) to 0.04 (matching IRON)</a:t>
+            </a:r>
+          </a:p>
+          <a:p>
+            <a:pPr>
+              <a:spcAft>
+                <a:spcPts val="300"/>
+              </a:spcAft>
+              <a:defRPr sz="1200" b="0"/>
+            </a:pPr>
+          </a:p>
+          <a:p>
+            <a:pPr>
+              <a:spcAft>
+                <a:spcPts val="300"/>
+              </a:spcAft>
+              <a:defRPr sz="1200" b="1">
+                <a:solidFill>
+                  <a:srgbClr val="ED1C24"/>
+                </a:solidFill>
+              </a:defRPr>
+            </a:pPr>
+            <a:r>
+              <a:t>Key insight: realistic inputs + strict thresholds + correlation = find bugs that PASS! hides</a:t>
+            </a:r>
+          </a:p>
+        </p:txBody>
+      </p:sp>
+    </p:spTree>
+  </p:cSld>
+  <p:clrMapOvr>
+    <a:masterClrMapping/>
+  </p:clrMapOvr>
+</p:sld>
+</file>
+
+<file path=ppt/slides/slide14.xml><?xml version="1.0" encoding="utf-8"?>
+<p:sld xmlns:a="http://schemas.openxmlformats.org/drawingml/2006/main" xmlns:p="http://schemas.openxmlformats.org/presentationml/2006/main" xmlns:r="http://schemas.openxmlformats.org/officeDocument/2006/relationships">
+  <p:cSld>
+    <p:spTree>
+      <p:nvGrpSpPr>
+        <p:cNvPr id="1" name=""/>
+        <p:cNvGrpSpPr/>
+        <p:nvPr/>
+      </p:nvGrpSpPr>
+      <p:grpSpPr/>
+      <p:sp>
+        <p:nvSpPr>
+          <p:cNvPr id="2" name="Title 1"/>
+          <p:cNvSpPr>
+            <a:spLocks noGrp="1"/>
+          </p:cNvSpPr>
+          <p:nvPr>
+            <p:ph type="title"/>
+          </p:nvPr>
+        </p:nvSpPr>
+        <p:spPr/>
+        <p:txBody>
+          <a:bodyPr/>
+          <a:lstStyle/>
+          <a:p>
+            <a:r>
+              <a:t>Methodology: Documentation-Driven Development</a:t>
+            </a:r>
+          </a:p>
+        </p:txBody>
+      </p:sp>
+      <p:sp>
+        <p:nvSpPr>
+          <p:cNvPr id="3" name="Content Placeholder 2"/>
+          <p:cNvSpPr>
+            <a:spLocks noGrp="1"/>
+          </p:cNvSpPr>
+          <p:nvPr>
+            <p:ph idx="10" sz="quarter"/>
+          </p:nvPr>
+        </p:nvSpPr>
+        <p:spPr/>
+        <p:txBody>
+          <a:bodyPr/>
+          <a:lstStyle/>
+          <a:p>
+            <a:pPr>
+              <a:defRPr sz="1300"/>
+            </a:pPr>
+            <a:r>
+              <a:t>Structured approach across multiple working sessions:</a:t>
+            </a:r>
+          </a:p>
+          <a:p>
+            <a:pPr>
+              <a:spcBef>
+                <a:spcPts val="100"/>
+              </a:spcBef>
+              <a:spcAft>
+                <a:spcPts val="400"/>
+              </a:spcAft>
+              <a:defRPr sz="400"/>
+            </a:pPr>
+          </a:p>
+          <a:p>
+            <a:pPr>
+              <a:spcBef>
+                <a:spcPts val="100"/>
+              </a:spcBef>
+              <a:spcAft>
+                <a:spcPts val="400"/>
+              </a:spcAft>
+              <a:defRPr sz="1400"/>
+            </a:pPr>
+            <a:r>
+              <a:rPr sz="1400" b="1">
+                <a:solidFill>
+                  <a:srgbClr val="ED1C24"/>
+                </a:solidFill>
+              </a:rPr>
+              <a:t>Phased roadmap with clear entry/exit criteria</a:t>
+            </a:r>
+          </a:p>
+          <a:p>
+            <a:pPr lvl="1">
+              <a:spcBef>
+                <a:spcPts val="100"/>
+              </a:spcBef>
+              <a:spcAft>
+                <a:spcPts val="400"/>
+              </a:spcAft>
+              <a:defRPr sz="1200"/>
+            </a:pPr>
+            <a:r>
+              <a:rPr sz="1200" b="0"/>
+              <a:t>Infrastructure -&gt; Kernel validation -&gt; Single layer -&gt; Full model -&gt; Performance</a:t>
+            </a:r>
+          </a:p>
+          <a:p>
+            <a:pPr lvl="1">
+              <a:spcBef>
+                <a:spcPts val="100"/>
+              </a:spcBef>
+              <a:spcAft>
+                <a:spcPts val="400"/>
+              </a:spcAft>
+              <a:defRPr sz="1200"/>
+            </a:pPr>
+            <a:r>
+              <a:rPr sz="1200" b="0"/>
+              <a:t>Correctness verified before each performance optimization step</a:t>
+            </a:r>
+          </a:p>
+          <a:p>
+            <a:pPr>
+              <a:spcBef>
+                <a:spcPts val="100"/>
+              </a:spcBef>
+              <a:spcAft>
+                <a:spcPts val="400"/>
+              </a:spcAft>
+              <a:defRPr sz="1400"/>
+            </a:pPr>
+            <a:r>
+              <a:rPr sz="1400" b="1">
+                <a:solidFill>
+                  <a:srgbClr val="ED1C24"/>
+                </a:solidFill>
+              </a:rPr>
+              <a:t>Living documentation (8+ docs maintained throughout)</a:t>
+            </a:r>
+          </a:p>
+          <a:p>
+            <a:pPr lvl="1">
+              <a:spcBef>
+                <a:spcPts val="100"/>
+              </a:spcBef>
+              <a:spcAft>
+                <a:spcPts val="400"/>
+              </a:spcAft>
+              <a:defRPr sz="1200"/>
+            </a:pPr>
+            <a:r>
+              <a:rPr sz="1200" b="0"/>
+              <a:t>LLAMA_PLAN.md: single-page status overview for session restoration</a:t>
+            </a:r>
+          </a:p>
+          <a:p>
+            <a:pPr lvl="1">
+              <a:spcBef>
+                <a:spcPts val="100"/>
+              </a:spcBef>
+              <a:spcAft>
+                <a:spcPts val="400"/>
+              </a:spcAft>
+              <a:defRPr sz="1200"/>
+            </a:pPr>
+            <a:r>
+              <a:rPr sz="1200" b="0"/>
+              <a:t>perf_opt_prefill.md: optimization timeline with per-step measurements</a:t>
+            </a:r>
+          </a:p>
+          <a:p>
+            <a:pPr lvl="1">
+              <a:spcBef>
+                <a:spcPts val="100"/>
+              </a:spcBef>
+              <a:spcAft>
+                <a:spcPts val="400"/>
+              </a:spcAft>
+              <a:defRPr sz="1200"/>
+            </a:pPr>
+            <a:r>
+              <a:rPr sz="1200" b="0"/>
+              <a:t>Per-kernel analysis docs and compiler bug reports with reproducers</a:t>
+            </a:r>
+          </a:p>
+          <a:p>
+            <a:pPr>
+              <a:spcBef>
+                <a:spcPts val="100"/>
+              </a:spcBef>
+              <a:spcAft>
+                <a:spcPts val="400"/>
+              </a:spcAft>
+              <a:defRPr sz="1400"/>
+            </a:pPr>
+            <a:r>
+              <a:rPr sz="1400" b="1">
+                <a:solidFill>
+                  <a:srgbClr val="ED1C24"/>
+                </a:solidFill>
+              </a:rPr>
+              <a:t>Claude Code as development partner</a:t>
+            </a:r>
+          </a:p>
+          <a:p>
+            <a:pPr lvl="1">
+              <a:spcBef>
+                <a:spcPts val="100"/>
+              </a:spcBef>
+              <a:spcAft>
+                <a:spcPts val="400"/>
+              </a:spcAft>
+              <a:defRPr sz="1200"/>
+            </a:pPr>
+            <a:r>
+              <a:rPr sz="1200" b="0"/>
+              <a:t>Plan mode for design, subagents for parallel exploration, auto-memory for context</a:t>
+            </a:r>
+          </a:p>
+          <a:p>
+            <a:pPr lvl="1">
+              <a:spcBef>
+                <a:spcPts val="100"/>
+              </a:spcBef>
+              <a:spcAft>
+                <a:spcPts val="400"/>
+              </a:spcAft>
+              <a:defRPr sz="1200"/>
+            </a:pPr>
+            <a:r>
+              <a:rPr sz="1200" b="0"/>
+              <a:t>Iterative loop: change -&gt; compile -&gt; run -&gt; profile -&gt; compare -&gt; decide next</a:t>
+            </a:r>
+          </a:p>
+          <a:p>
+            <a:pPr lvl="1">
+              <a:spcBef>
+                <a:spcPts val="100"/>
+              </a:spcBef>
+              <a:spcAft>
+                <a:spcPts val="400"/>
+              </a:spcAft>
+              <a:defRPr sz="1200"/>
+            </a:pPr>
+            <a:r>
+              <a:rPr sz="1200" b="0"/>
+              <a:t>Documentation-first: each session starts by reading LLAMA_PLAN.md</a:t>
+            </a:r>
+          </a:p>
+        </p:txBody>
+      </p:sp>
+    </p:spTree>
+  </p:cSld>
+  <p:clrMapOvr>
+    <a:masterClrMapping/>
+  </p:clrMapOvr>
+</p:sld>
+</file>
+
+<file path=ppt/slides/slide15.xml><?xml version="1.0" encoding="utf-8"?>
 <p:sld xmlns:a="http://schemas.openxmlformats.org/drawingml/2006/main" xmlns:p="http://schemas.openxmlformats.org/presentationml/2006/main" xmlns:r="http://schemas.openxmlformats.org/officeDocument/2006/relationships">
   <p:cSld>
     <p:spTree>
@@ -21263,7 +22200,7 @@
 </p:sld>
 </file>
 
-<file path=ppt/slides/slide14.xml><?xml version="1.0" encoding="utf-8"?>
+<file path=ppt/slides/slide16.xml><?xml version="1.0" encoding="utf-8"?>
 <p:sld xmlns:a="http://schemas.openxmlformats.org/drawingml/2006/main" xmlns:p="http://schemas.openxmlformats.org/presentationml/2006/main" xmlns:r="http://schemas.openxmlformats.org/officeDocument/2006/relationships">
   <p:cSld>
     <p:spTree>
@@ -21554,7 +22491,7 @@
 </p:sld>
 </file>
 
-<file path=ppt/slides/slide15.xml><?xml version="1.0" encoding="utf-8"?>
+<file path=ppt/slides/slide17.xml><?xml version="1.0" encoding="utf-8"?>
 <p:sld xmlns:a="http://schemas.openxmlformats.org/drawingml/2006/main" xmlns:p="http://schemas.openxmlformats.org/presentationml/2006/main" xmlns:r="http://schemas.openxmlformats.org/officeDocument/2006/relationships">
   <p:cSld>
     <p:spTree>

</xml_diff>